<commit_message>
data-eng 2-5 덱 s0 — 3.9 서술 정정(오늘은 된다)
</commit_message>
<xml_diff>
--- a/data-eng/decks/w2d5s0.pptx
+++ b/data-eng/decks/w2d5s0.pptx
@@ -6261,7 +6261,7 @@
                 <a:ea typeface="Pretendard"/>
                 <a:cs typeface="Pretendard"/>
               </a:rPr>
-              <a:t>3.10 이상 — 3.9 면 오늘 코드가 import 에서 TypeError (실측)</a:t>
+              <a:t>3.10 이상 권장 — 3.9 는 오늘은 되지만(첫 줄 __future__) 다음 주 코드에서 막힌다</a:t>
             </a:r>
           </a:p>
         </p:txBody>
@@ -8955,7 +8955,7 @@
                 <a:ea typeface="Pretendard"/>
                 <a:cs typeface="Pretendard"/>
               </a:rPr>
-              <a:t>3.10 이상 설치 뒤</a:t>
+              <a:t>오늘은 된다 — 이번 주 안에</a:t>
             </a:r>
           </a:p>
           <a:p>
@@ -8973,7 +8973,7 @@
                 <a:ea typeface="Pretendard"/>
                 <a:cs typeface="Pretendard"/>
               </a:rPr>
-              <a:t>.venv 다시 만들기</a:t>
+              <a:t>3.10 이상으로 .venv 다시</a:t>
             </a:r>
           </a:p>
         </p:txBody>

</xml_diff>